<commit_message>
Recheck Semester 1 Week 2: slide wording fixes and notebook intro wording
- 1 Lecture: slide 14 "bin medians" and spacing, slide 30 spacing,
  slide 23 speaker-note typos, slide 5 "or files", slides 5 and 14 point
  discretization to Week 3 (pd.cut), slide 35 grammar, slide 10 spacing,
  slide 2 book authors
- 3 Tutorial: notebooks 06 and 07 say "notebook" instead of "lecture"

Co-Authored-By: Claude Opus 5.5 <noreply@anthropic.com>
Claude-Session: https://claude.ai/code/session_0178AmQ8StF3gdMxNmDacgoL
[skip ci]
</commit_message>
<xml_diff>
--- a/content/Lectures/Semester 1/Week 2/1 Lecture/1.2 Data Preprocessing (Lecture).pptx
+++ b/content/Lectures/Semester 1/Week 2/1 Lecture/1.2 Data Preprocessing (Lecture).pptx
@@ -1693,7 +1693,7 @@
             </a:r>
             <a:r>
               <a:rPr lang="en-GB" altLang="en-US" i="1"/>
-              <a:t> Maximum absolute value in given data(m): 701</a:t>
+              <a:t> Maximum absolute value in given data (m): 701</a:t>
             </a:r>
             <a:br>
               <a:rPr lang="en-GB" altLang="en-US" i="1"/>
@@ -1704,7 +1704,7 @@
             </a:r>
             <a:r>
               <a:rPr lang="en-GB" altLang="en-US" i="1"/>
-              <a:t>Divide the given data by 1000 (i.e j=3)</a:t>
+              <a:t>Divide the given data by 1000 (i.e. j = 3)</a:t>
             </a:r>
           </a:p>
           <a:p>
@@ -5127,7 +5127,7 @@
             </a:pPr>
             <a:r>
               <a:rPr lang="en-US" altLang="en-US" sz="2000"/>
-              <a:t>Ignore the tuple:  usually done when class label is missing (assuming the task is classification</a:t>
+              <a:t>Ignore the tuple: usually done when class label is missing (assuming the task is classification</a:t>
             </a:r>
             <a:r>
               <a:rPr lang="en-US" altLang="en-US" sz="2000">
@@ -6371,7 +6371,7 @@
                   <a:schemeClr val="accent2"/>
                 </a:solidFill>
               </a:rPr>
-              <a:t>smooth by bin means,  smooth by bin median, smooth by bin boundaries</a:t>
+              <a:t>smooth by bin means, smooth by bin medians, smooth by bin boundaries</a:t>
             </a:r>
             <a:r>
               <a:rPr lang="en-US" altLang="en-US" sz="2200"/>
@@ -6382,7 +6382,7 @@
             <a:pPr lvl="1" eaLnBrk="1" hangingPunct="1"/>
             <a:r>
               <a:rPr lang="en-US" altLang="en-US" sz="2200"/>
-              <a:t>used also for discretization (discussed later)</a:t>
+              <a:t>used also for discretization (practised in Week 3)</a:t>
             </a:r>
           </a:p>
           <a:p>
@@ -17467,7 +17467,7 @@
             <a:pPr eaLnBrk="1" hangingPunct="1"/>
             <a:r>
               <a:rPr lang="en-GB" altLang="en-US"/>
-              <a:t>The lecture slides are based on the book: Data Mining: Concepts and Techniques, </a:t>
+              <a:t>The lecture slides are based on the book: Data Mining: Concepts and Techniques (Han, Kamber and Pei), </a:t>
             </a:r>
             <a:r>
               <a:rPr lang="en-GB" altLang="en-US" i="1"/>
@@ -21717,7 +21717,7 @@
             </a:pPr>
             <a:r>
               <a:rPr lang="en-US" altLang="en-US" sz="2000"/>
-              <a:t> Using the strongest components one can reconstruct a good approximation of the   original signal.</a:t>
+              <a:t> Using the strongest components one can reconstruct a good approximation of the original signal.</a:t>
             </a:r>
           </a:p>
         </p:txBody>
@@ -31438,7 +31438,7 @@
             </a:pPr>
             <a:r>
               <a:rPr lang="en-US" altLang="en-US" sz="2000"/>
-              <a:t>A lot of methods have been developed in data pre-processing but still an active area of research</a:t>
+              <a:t>A lot of methods have been developed in data pre-processing but it is still an active area of research</a:t>
             </a:r>
           </a:p>
           <a:p>
@@ -31899,7 +31899,7 @@
             </a:r>
             <a:r>
               <a:rPr lang="en-US" altLang="en-US" sz="1400"/>
-              <a:t>, files, or notes</a:t>
+              <a:t>, or files</a:t>
             </a:r>
           </a:p>
           <a:p>
@@ -31968,7 +31968,7 @@
             <a:pPr lvl="1" indent="-182563" eaLnBrk="1" hangingPunct="1"/>
             <a:r>
               <a:rPr lang="en-US" altLang="en-US" sz="1400"/>
-              <a:t>We will discuss this in detail later </a:t>
+              <a:t>We will practise this in Week 3 (pd.cut) </a:t>
             </a:r>
           </a:p>
         </p:txBody>

</xml_diff>